<commit_message>
Gộp hướng dẫn cài đặt, chạy demo và thực hành vào một file
README và HUONG-DAN.pdf thành hướng dẫn chung: chuẩn bị trước buổi học, cài thư viện, chạy demo, thực hành, chạy sandbox thật, xử lý lỗi. Bỏ THUC-HANH.md vì nội dung đã nằm trong hướng dẫn chung.
</commit_message>
<xml_diff>
--- a/VNPAY-Seminar.pptx
+++ b/VNPAY-Seminar.pptx
@@ -3866,7 +3866,7 @@
           <a:p>
             <a:r>
               <a:rPr lang="vi-VN" sz="1600" dirty="0"/>
-              <a:t>Làm mẫu bài 3 trên máy chiếu trước, rồi cho cả lớp làm. Chi tiết từng bước có trong THUC-HANH.md.</a:t>
+              <a:t>Làm mẫu bài 3 trên máy chiếu trước, rồi cho cả lớp làm. Chi tiết từng bước có trong HUONG-DAN.pdf, mục 5.</a:t>
             </a:r>
           </a:p>
           <a:p>
@@ -43371,7 +43371,7 @@
         <p:spPr>
           <a:xfrm>
             <a:off x="7276887" y="2812146"/>
-            <a:ext cx="2431847" cy="209580"/>
+            <a:ext cx="2953146" cy="209580"/>
           </a:xfrm>
           <a:prstGeom prst="rect">
             <a:avLst/>
@@ -43395,7 +43395,7 @@
                 <a:ea typeface="Arial" pitchFamily="34" charset="-122"/>
                 <a:cs typeface="Arial" pitchFamily="34" charset="-120"/>
               </a:rPr>
-              <a:t>Hướng dẫn chi tiết: THUC-HANH.md</a:t>
+              <a:t>Hướng dẫn chi tiết: HUONG-DAN.pdf, mục 5</a:t>
             </a:r>
             <a:endParaRPr lang="en-US" sz="1100" dirty="0"/>
           </a:p>

</xml_diff>